<commit_message>
Add Vivado synthesis reports
</commit_message>
<xml_diff>
--- a/docs/rv32i_int8_cnn_project_ppt.pptx
+++ b/docs/rv32i_int8_cnn_project_ppt.pptx
@@ -5375,7 +5375,7 @@
                 <a:latin typeface="Microsoft YaHei"/>
                 <a:ea typeface="Microsoft YaHei"/>
               </a:rPr>
-              <a:t>结果、综合状态与限制</a:t>
+              <a:t>结果、Vivado 综合与限制</a:t>
             </a:r>
           </a:p>
         </p:txBody>
@@ -5412,7 +5412,7 @@
                 <a:latin typeface="Microsoft YaHei"/>
                 <a:ea typeface="Microsoft YaHei"/>
               </a:rPr>
-              <a:t>功能闭环已跑通；真实综合工具本机未安装，已补可复现实验脚本</a:t>
+              <a:t>功能闭环已跑通；Vivado 2021.2 已给出代表模块资源趋势</a:t>
             </a:r>
           </a:p>
         </p:txBody>
@@ -5741,83 +5741,83 @@
         </p:nvSpPr>
         <p:spPr>
           <a:xfrm>
-            <a:off x="786384" y="2423160"/>
-            <a:ext cx="5029200" cy="1463040"/>
-          </a:xfrm>
-          <a:prstGeom prst="rect">
-            <a:avLst/>
-          </a:prstGeom>
-          <a:noFill/>
-          <a:ln>
-            <a:noFill/>
-          </a:ln>
-        </p:spPr>
-        <p:txBody>
-          <a:bodyPr wrap="square" lIns="0" tIns="0" rIns="0" bIns="0"/>
-          <a:lstStyle/>
-          <a:p>
-            <a:pPr algn="l"/>
-            <a:r>
-              <a:rPr lang="zh-CN" sz="1700" b="0">
+            <a:off x="786384" y="2331720"/>
+            <a:ext cx="5440680" cy="1417320"/>
+          </a:xfrm>
+          <a:prstGeom prst="rect">
+            <a:avLst/>
+          </a:prstGeom>
+          <a:noFill/>
+          <a:ln>
+            <a:noFill/>
+          </a:ln>
+        </p:spPr>
+        <p:txBody>
+          <a:bodyPr wrap="square" lIns="0" tIns="0" rIns="0" bIns="0"/>
+          <a:lstStyle/>
+          <a:p>
+            <a:pPr algn="l"/>
+            <a:r>
+              <a:rPr lang="zh-CN" sz="1500" b="0">
                 <a:solidFill>
                   <a:srgbClr val="344054"/>
                 </a:solidFill>
                 <a:latin typeface="Microsoft YaHei"/>
                 <a:ea typeface="Microsoft YaHei"/>
               </a:rPr>
-              <a:t>真实综合尝试</a:t>
-            </a:r>
-          </a:p>
-          <a:p>
-            <a:pPr algn="l"/>
-            <a:r>
-              <a:rPr lang="zh-CN" sz="1700" b="0">
+              <a:t>Vivado 2021.2 / K26 OOC</a:t>
+            </a:r>
+          </a:p>
+          <a:p>
+            <a:pPr algn="l"/>
+            <a:r>
+              <a:rPr lang="zh-CN" sz="1500" b="0">
                 <a:solidFill>
                   <a:srgbClr val="344054"/>
                 </a:solidFill>
                 <a:latin typeface="Microsoft YaHei"/>
                 <a:ea typeface="Microsoft YaHei"/>
               </a:rPr>
-              <a:t>• Windows PATH: Yosys/Vivado not found</a:t>
-            </a:r>
-          </a:p>
-          <a:p>
-            <a:pPr algn="l"/>
-            <a:r>
-              <a:rPr lang="zh-CN" sz="1700" b="0">
+              <a:t>• requant: 494 LUT, 294 FF, 10 DSP</a:t>
+            </a:r>
+          </a:p>
+          <a:p>
+            <a:pPr algn="l"/>
+            <a:r>
+              <a:rPr lang="zh-CN" sz="1500" b="0">
                 <a:solidFill>
                   <a:srgbClr val="344054"/>
                 </a:solidFill>
                 <a:latin typeface="Microsoft YaHei"/>
                 <a:ea typeface="Microsoft YaHei"/>
               </a:rPr>
-              <a:t>• WSL: yosys/vivado command not found</a:t>
-            </a:r>
-          </a:p>
-          <a:p>
-            <a:pPr algn="l"/>
-            <a:r>
-              <a:rPr lang="zh-CN" sz="1700" b="0">
+              <a:t>• PW 8x8: 5957 LUT, 4098 FF, 0 DSP</a:t>
+            </a:r>
+          </a:p>
+          <a:p>
+            <a:pPr algn="l"/>
+            <a:r>
+              <a:rPr lang="zh-CN" sz="1500" b="0">
                 <a:solidFill>
                   <a:srgbClr val="344054"/>
                 </a:solidFill>
                 <a:latin typeface="Microsoft YaHei"/>
                 <a:ea typeface="Microsoft YaHei"/>
               </a:rPr>
-              <a:t>• 已新增 scripts/run_synthesis_yosys.sh</a:t>
-            </a:r>
-          </a:p>
-          <a:p>
-            <a:pPr algn="l"/>
-            <a:r>
-              <a:rPr lang="zh-CN" sz="1700" b="0">
+              <a:t>• DW lanes: 9759 LUT, 3367 FF, 0 DSP</a:t>
+            </a:r>
+          </a:p>
+          <a:p>
+            <a:pPr algn="l"/>
+            <a:r>
+              <a:rPr lang="zh-CN" sz="1500" b="0">
                 <a:solidFill>
                   <a:srgbClr val="344054"/>
                 </a:solidFill>
                 <a:latin typeface="Microsoft YaHei"/>
                 <a:ea typeface="Microsoft YaHei"/>
               </a:rPr>
-              <a:t>• 报告: build/reports/synthesis_initial.md</a:t>
+              <a:t>• SRAM bank: 6791 LUT, 0 BRAM</a:t>
             </a:r>
           </a:p>
         </p:txBody>
@@ -5830,83 +5830,83 @@
         </p:nvSpPr>
         <p:spPr>
           <a:xfrm>
-            <a:off x="6400800" y="2423160"/>
-            <a:ext cx="4526280" cy="1463040"/>
-          </a:xfrm>
-          <a:prstGeom prst="rect">
-            <a:avLst/>
-          </a:prstGeom>
-          <a:noFill/>
-          <a:ln>
-            <a:noFill/>
-          </a:ln>
-        </p:spPr>
-        <p:txBody>
-          <a:bodyPr wrap="square" lIns="0" tIns="0" rIns="0" bIns="0"/>
-          <a:lstStyle/>
-          <a:p>
-            <a:pPr algn="l"/>
-            <a:r>
-              <a:rPr lang="zh-CN" sz="1700" b="0">
+            <a:off x="6537960" y="2331720"/>
+            <a:ext cx="4434840" cy="1417320"/>
+          </a:xfrm>
+          <a:prstGeom prst="rect">
+            <a:avLst/>
+          </a:prstGeom>
+          <a:noFill/>
+          <a:ln>
+            <a:noFill/>
+          </a:ln>
+        </p:spPr>
+        <p:txBody>
+          <a:bodyPr wrap="square" lIns="0" tIns="0" rIns="0" bIns="0"/>
+          <a:lstStyle/>
+          <a:p>
+            <a:pPr algn="l"/>
+            <a:r>
+              <a:rPr lang="zh-CN" sz="1500" b="0">
                 <a:solidFill>
                   <a:srgbClr val="344054"/>
                 </a:solidFill>
                 <a:latin typeface="Microsoft YaHei"/>
                 <a:ea typeface="Microsoft YaHei"/>
               </a:rPr>
-              <a:t>当前限制</a:t>
-            </a:r>
-          </a:p>
-          <a:p>
-            <a:pPr algn="l"/>
-            <a:r>
-              <a:rPr lang="zh-CN" sz="1700" b="0">
+              <a:t>full cnn_top synthesis</a:t>
+            </a:r>
+          </a:p>
+          <a:p>
+            <a:pPr algn="l"/>
+            <a:r>
+              <a:rPr lang="zh-CN" sz="1500" b="0">
                 <a:solidFill>
                   <a:srgbClr val="344054"/>
                 </a:solidFill>
                 <a:latin typeface="Microsoft YaHei"/>
                 <a:ea typeface="Microsoft YaHei"/>
               </a:rPr>
-              <a:t>• word-per-int8 仿真内存格式</a:t>
-            </a:r>
-          </a:p>
-          <a:p>
-            <a:pPr algn="l"/>
-            <a:r>
-              <a:rPr lang="zh-CN" sz="1700" b="0">
+              <a:t>• 启动成功并进入 layer_runner</a:t>
+            </a:r>
+          </a:p>
+          <a:p>
+            <a:pPr algn="l"/>
+            <a:r>
+              <a:rPr lang="zh-CN" sz="1500" b="0">
                 <a:solidFill>
                   <a:srgbClr val="344054"/>
                 </a:solidFill>
                 <a:latin typeface="Microsoft YaHei"/>
                 <a:ea typeface="Microsoft YaHei"/>
               </a:rPr>
-              <a:t>• SRAM/BRAM inference 待综合确认</a:t>
-            </a:r>
-          </a:p>
-          <a:p>
-            <a:pPr algn="l"/>
-            <a:r>
-              <a:rPr lang="zh-CN" sz="1700" b="0">
+              <a:t>• 卡在 dw_tile_buffer</a:t>
+            </a:r>
+          </a:p>
+          <a:p>
+            <a:pPr algn="l"/>
+            <a:r>
+              <a:rPr lang="zh-CN" sz="1500" b="0">
                 <a:solidFill>
                   <a:srgbClr val="344054"/>
                 </a:solidFill>
                 <a:latin typeface="Microsoft YaHei"/>
                 <a:ea typeface="Microsoft YaHei"/>
               </a:rPr>
-              <a:t>• 单时钟，未做 CDC</a:t>
-            </a:r>
-          </a:p>
-          <a:p>
-            <a:pPr algn="l"/>
-            <a:r>
-              <a:rPr lang="zh-CN" sz="1700" b="0">
+              <a:t>• Vivado: 3D RAM pattern unsupported</a:t>
+            </a:r>
+          </a:p>
+          <a:p>
+            <a:pPr algn="l"/>
+            <a:r>
+              <a:rPr lang="zh-CN" sz="1500" b="0">
                 <a:solidFill>
                   <a:srgbClr val="344054"/>
                 </a:solidFill>
                 <a:latin typeface="Microsoft YaHei"/>
                 <a:ea typeface="Microsoft YaHei"/>
               </a:rPr>
-              <a:t>• 约 50% checkpoint 用于功能验证</a:t>
+              <a:t>• 当前首要任务是显式 banking / RAM wrapper</a:t>
             </a:r>
           </a:p>
         </p:txBody>
@@ -5963,14 +5963,14 @@
           <a:p>
             <a:pPr algn="ctr"/>
             <a:r>
-              <a:rPr lang="zh-CN" sz="1900" b="1">
-                <a:solidFill>
-                  <a:srgbClr val="101828"/>
-                </a:solidFill>
-                <a:latin typeface="Microsoft YaHei"/>
-                <a:ea typeface="Microsoft YaHei"/>
-              </a:rPr>
-              <a:t>下一步: 跑真实 FPGA synthesis，确认 BRAM/DSP/timing；再做 requant 流水化、PW 控制复制、packed NHWC loader、QAT/calibration。</a:t>
+              <a:rPr lang="zh-CN" sz="1800" b="1">
+                <a:solidFill>
+                  <a:srgbClr val="101828"/>
+                </a:solidFill>
+                <a:latin typeface="Microsoft YaHei"/>
+                <a:ea typeface="Microsoft YaHei"/>
+              </a:rPr>
+              <a:t>下一步: 重写 DW tile buffer / SRAM bank 以获得 BRAM-friendly top synthesis，再做 timing closure、requant 复用、PW 控制复制。</a:t>
             </a:r>
           </a:p>
         </p:txBody>

</xml_diff>